<commit_message>
Roteiro falado do Squeeze 4 nas anotacoes dos slides
Substitui as anotacoes por texto corrido, exatamente como deve ser dito na
apresentacao. Saem as orientacoes de palco, os tempos por slide e os blocos
de "se perguntarem"; fica so a fala.

Texto fornecido pelo grupo, aplicado sem alteracao de conteudo. Uma unica
correcao de forma: o trecho do slide 6 chegou com caracteres corrompidos
("Aplic...") e foi restaurado como "Aplicativos diretos das companhias",
que e o que o slide mostra.

1.051 palavras no total, cerca de 8 minutos falados a 130 palavras por
minuto - cabe nos 10 minutos do Squeeze com folga para transicoes.

Co-Authored-By: Claude Opus 5 <noreply@anthropic.com>
</commit_message>
<xml_diff>
--- a/sprints/sprint-04/entregaveis/Sprint_04_Kairos_Antevia.pptx
+++ b/sprints/sprint-04/entregaveis/Sprint_04_Kairos_Antevia.pptx
@@ -512,50 +512,7 @@
           <a:lstStyle/>
           <a:p>
             <a:r>
-              <a:t>[ 20 segundos ]</a:t>
-            </a:r>
-          </a:p>
-          <a:p/>
-          <a:p>
-            <a:r>
-              <a:t>ABERTURA</a:t>
-            </a:r>
-          </a:p>
-          <a:p>
-            <a:r>
-              <a:t>"Sprint 4: a hora de transformar a Antévia em números. Vamos mostrar quanto o</a:t>
-            </a:r>
-          </a:p>
-          <a:p>
-            <a:r>
-              <a:t>negócio fatura em três anos, de onde vem cada real, e por que o primeiro ano é</a:t>
-            </a:r>
-          </a:p>
-          <a:p>
-            <a:r>
-              <a:t>a parte difícil."</a:t>
-            </a:r>
-          </a:p>
-          <a:p/>
-          <a:p>
-            <a:r>
-              <a:t>Não leia os números da capa em detalhe — eles voltam no fechamento.</a:t>
-            </a:r>
-          </a:p>
-          <a:p/>
-          <a:p>
-            <a:r>
-              <a:t>DEIXE CLARO DE SAÍDA</a:t>
-            </a:r>
-          </a:p>
-          <a:p>
-            <a:r>
-              <a:t>Esta sprint trata só de RECEITA. Custos, despesas e investimentos são a Sprint 5.</a:t>
-            </a:r>
-          </a:p>
-          <a:p>
-            <a:r>
-              <a:t>Se alguém perguntar por margem ou lucro, a resposta é: "está na próxima sprint".</a:t>
+              <a:t>Boa apresentação a todos. Estamos aqui para detalhar a viabilidade da Antévia ao longo de doze trimestres, estruturada em três cenários. O nosso modelo projeta 1,10 milhão de reais em receita acumulada em três anos, mas o foco da nossa atenção hoje é o primeiro ano: um faturamento de 71 mil reais que representa o nosso verdadeiro teste de validação.</a:t>
             </a:r>
           </a:p>
         </p:txBody>
@@ -625,87 +582,7 @@
           <a:lstStyle/>
           <a:p>
             <a:r>
-              <a:t>[ 45 segundos ]</a:t>
-            </a:r>
-          </a:p>
-          <a:p/>
-          <a:p>
-            <a:r>
-              <a:t>O QUE FALAR</a:t>
-            </a:r>
-          </a:p>
-          <a:p>
-            <a:r>
-              <a:t>"Movemos uma variável de cada vez, com as outras no cenário tendencial."</a:t>
-            </a:r>
-          </a:p>
-          <a:p/>
-          <a:p>
-            <a:r>
-              <a:t>"Captação de alunos: mais ou menos 30% muda a receita em mais ou menos 30%. É a</a:t>
-            </a:r>
-          </a:p>
-          <a:p>
-            <a:r>
-              <a:t>dominante."</a:t>
-            </a:r>
-          </a:p>
-          <a:p>
-            <a:r>
-              <a:t>"Taxa de serviço: 25%."</a:t>
-            </a:r>
-          </a:p>
-          <a:p>
-            <a:r>
-              <a:t>"Comissão: de menos 15 a mais 29%."</a:t>
-            </a:r>
-          </a:p>
-          <a:p/>
-          <a:p>
-            <a:r>
-              <a:t>O PONTO DO SLIDE — leia a faixa escura, é sobre método</a:t>
-            </a:r>
-          </a:p>
-          <a:p>
-            <a:r>
-              <a:t>"O que mais importa aqui não é o gráfico, é o que sumiu dele. As versões</a:t>
-            </a:r>
-          </a:p>
-          <a:p>
-            <a:r>
-              <a:t>anteriores deste modelo tinham cinco variáveis, duas delas frágeis: tamanho da</a:t>
-            </a:r>
-          </a:p>
-          <a:p>
-            <a:r>
-              <a:t>turma e taxa de adesão. As duas saíram quando passamos a contar aluno captado."</a:t>
-            </a:r>
-          </a:p>
-          <a:p/>
-          <a:p>
-            <a:r>
-              <a:t>"Sobraram três. Todas explicáveis numa frase. E a dominante é justamente a que</a:t>
-            </a:r>
-          </a:p>
-          <a:p>
-            <a:r>
-              <a:t>nós controlamos: quantos alunos conseguimos captar."</a:t>
-            </a:r>
-          </a:p>
-          <a:p/>
-          <a:p>
-            <a:r>
-              <a:t>SE PERGUNTAREM POR QUE A ADESÃO SUMIU</a:t>
-            </a:r>
-          </a:p>
-          <a:p>
-            <a:r>
-              <a:t>"Porque ela estava embutida numa conta que a gente não precisava fazer. Se eu</a:t>
-            </a:r>
-          </a:p>
-          <a:p>
-            <a:r>
-              <a:t>conto o aluno que aderiu, não preciso estimar quantos por cento da turma aderem."</a:t>
+              <a:t>Limpamos o modelo e restaram apenas três variáveis principais, sendo a dominante inteiramente nossa. Versões anteriores continham cinco variáveis, incluindo o tamanho da turma e a taxa de adesão interna, que foram completamente eliminadas ao adotar o aluno captado como unidade de medida. As variações de alunos captados, taxa de serviço e comissão demonstram que o que sobrou é direto de defender, e a alavanca principal está sob o nosso controle comercial direto.</a:t>
             </a:r>
           </a:p>
         </p:txBody>
@@ -775,113 +652,7 @@
           <a:lstStyle/>
           <a:p>
             <a:r>
-              <a:t>[ 40 segundos ]</a:t>
-            </a:r>
-          </a:p>
-          <a:p/>
-          <a:p>
-            <a:r>
-              <a:t>FECHAMENTO</a:t>
-            </a:r>
-          </a:p>
-          <a:p>
-            <a:r>
-              <a:t>"Fechando: R$ 1,10 milhão em três anos, e um primeiro ano de R$ 71 mil."</a:t>
-            </a:r>
-          </a:p>
-          <a:p/>
-          <a:p>
-            <a:r>
-              <a:t>SEJA DIRETO SOBRE O ANO 1 — é o que diferencia esta apresentação</a:t>
-            </a:r>
-          </a:p>
-          <a:p>
-            <a:r>
-              <a:t>"R$ 71 mil é menos de R$ 6 mil por mês. Não paga uma equipe. Ou os sócios operam</a:t>
-            </a:r>
-          </a:p>
-          <a:p>
-            <a:r>
-              <a:t>com as próprias mãos, ou é preciso capital para atravessar. Não estamos</a:t>
-            </a:r>
-          </a:p>
-          <a:p>
-            <a:r>
-              <a:t>escondendo isso — é a Sprint 5 que vai dizer quanto custa esse período."</a:t>
-            </a:r>
-          </a:p>
-          <a:p/>
-          <a:p>
-            <a:r>
-              <a:t>A VIRADA FINAL — a mensagem que deve ficar</a:t>
-            </a:r>
-          </a:p>
-          <a:p>
-            <a:r>
-              <a:t>"Mas o ano 1 não deveria ser medido por receita. Ele existe para produzir três</a:t>
-            </a:r>
-          </a:p>
-          <a:p>
-            <a:r>
-              <a:t>coisas: prova de que a operação funciona, volume acumulado que abre a faixa de</a:t>
-            </a:r>
-          </a:p>
-          <a:p>
-            <a:r>
-              <a:t>comissão, e concentração de alunos por campus que liga a tarifa de grupo."</a:t>
-            </a:r>
-          </a:p>
-          <a:p/>
-          <a:p>
-            <a:r>
-              <a:t>"A métrica do primeiro ano é quantos alunos captamos e onde eles estão. O</a:t>
-            </a:r>
-          </a:p>
-          <a:p>
-            <a:r>
-              <a:t>faturamento vem depois."</a:t>
-            </a:r>
-          </a:p>
-          <a:p/>
-          <a:p>
-            <a:r>
-              <a:t>ENCERRE</a:t>
-            </a:r>
-          </a:p>
-          <a:p>
-            <a:r>
-              <a:t>"Obrigado. Estamos à disposição."</a:t>
-            </a:r>
-          </a:p>
-          <a:p/>
-          <a:p>
-            <a:r>
-              <a:t>LEMBRETES PARA APRESENTAÇÃO ONLINE</a:t>
-            </a:r>
-          </a:p>
-          <a:p>
-            <a:r>
-              <a:t>- Fale a próxima frase antes de trocar o slide; evita o silêncio da transição.</a:t>
-            </a:r>
-          </a:p>
-          <a:p>
-            <a:r>
-              <a:t>- Nas tabelas, diga em que linha está antes de dar o número.</a:t>
-            </a:r>
-          </a:p>
-          <a:p>
-            <a:r>
-              <a:t>- Segure os slides 3, 4 e 8 — são os que mais geram pergunta.</a:t>
-            </a:r>
-          </a:p>
-          <a:p>
-            <a:r>
-              <a:t>- Tempo total: cerca de 10 minutos. Se atrasar, corte o slide 6 (pesquisa de</a:t>
-            </a:r>
-          </a:p>
-          <a:p>
-            <a:r>
-              <a:t>  preços), que é o mais dispensável.</a:t>
+              <a:t>Para fechar, reforçamos que o primeiro ano é o nosso grande desafio. No cenário tendencial, o ano um gera 71 mil reais de receita, o que significa menos de 6 mil reais por mês — um valor que não sustenta uma estrutura de equipe pesada. Por isso, a mensagem central é clara: o ano um não é medido por faturamento. Ele existe exclusivamente para produzir prova de execução, volume acumulado e concentração de campus. São exatamente esses três ativos que destravam o sucesso comercial e financeiro das fases seguintes.</a:t>
             </a:r>
           </a:p>
         </p:txBody>
@@ -951,140 +722,7 @@
           <a:lstStyle/>
           <a:p>
             <a:r>
-              <a:t>[ 60 segundos ]</a:t>
-            </a:r>
-          </a:p>
-          <a:p/>
-          <a:p>
-            <a:r>
-              <a:t>O QUE FALAR</a:t>
-            </a:r>
-          </a:p>
-          <a:p>
-            <a:r>
-              <a:t>"Vendemos um serviço de concierge cobrado por módulo. Duas fontes de receita:</a:t>
-            </a:r>
-          </a:p>
-          <a:p>
-            <a:r>
-              <a:t>uma taxa de R$ 100 que o aluno paga, e uma comissão que os fornecedores nos</a:t>
-            </a:r>
-          </a:p>
-          <a:p>
-            <a:r>
-              <a:t>pagam sobre o volume."</a:t>
-            </a:r>
-          </a:p>
-          <a:p/>
-          <a:p>
-            <a:r>
-              <a:t>"A meta do ano 1 é captar 100 alunos — somando todas as turmas e todas as</a:t>
-            </a:r>
-          </a:p>
-          <a:p>
-            <a:r>
-              <a:t>instituições. Essa é a unidade do nosso modelo."</a:t>
-            </a:r>
-          </a:p>
-          <a:p/>
-          <a:p>
-            <a:r>
-              <a:t>PONTO IMPORTANTE (o card do meio)</a:t>
-            </a:r>
-          </a:p>
-          <a:p>
-            <a:r>
-              <a:t>"Reparem que a comissão começa em 3% e só chega a 6,4% no ano 3. Ela cresce com</a:t>
-            </a:r>
-          </a:p>
-          <a:p>
-            <a:r>
-              <a:t>o volume. Não assumimos poder de negociação que não temos — e é disso que trata</a:t>
-            </a:r>
-          </a:p>
-          <a:p>
-            <a:r>
-              <a:t>o próximo slide."</a:t>
-            </a:r>
-          </a:p>
-          <a:p/>
-          <a:p>
-            <a:r>
-              <a:t>SE PERGUNTAREM: "POR QUE O CUSTO PARA A ESCOLA É ZERO?"</a:t>
-            </a:r>
-          </a:p>
-          <a:p>
-            <a:r>
-              <a:t>Essa é a pergunta mais provável deste slide. Resposta:</a:t>
-            </a:r>
-          </a:p>
-          <a:p/>
-          <a:p>
-            <a:r>
-              <a:t>"A escola não desembolsa nada. Ela entra com três coisas que já tem: o CNPJ, que</a:t>
-            </a:r>
-          </a:p>
-          <a:p>
-            <a:r>
-              <a:t>é o que viabiliza a tarifa de grupo; o acesso à turma no momento da matrícula; e</a:t>
-            </a:r>
-          </a:p>
-          <a:p>
-            <a:r>
-              <a:t>o calendário com as datas dos módulos."</a:t>
-            </a:r>
-          </a:p>
-          <a:p/>
-          <a:p>
-            <a:r>
-              <a:t>"Isso é uma decisão de desenho, não um esquecimento. Se a escola precisasse</a:t>
-            </a:r>
-          </a:p>
-          <a:p>
-            <a:r>
-              <a:t>aprovar verba, a venda entraria numa fila orçamentária e levaria um ano. Sem</a:t>
-            </a:r>
-          </a:p>
-          <a:p>
-            <a:r>
-              <a:t>desembolso, a decisão é da coordenação e sai rápido."</a:t>
-            </a:r>
-          </a:p>
-          <a:p/>
-          <a:p>
-            <a:r>
-              <a:t>"E ela ganha: NPS, aluno chegando menos estressado, zero atrito operacional.</a:t>
-            </a:r>
-          </a:p>
-          <a:p>
-            <a:r>
-              <a:t>Existe ainda um fee de escola como receita futura, mas deixamos fora da projeção</a:t>
-            </a:r>
-          </a:p>
-          <a:p>
-            <a:r>
-              <a:t>de propósito — cobrar da escola destruiria justamente o que torna a venda fácil."</a:t>
-            </a:r>
-          </a:p>
-          <a:p/>
-          <a:p>
-            <a:r>
-              <a:t>SE PERGUNTAREM: "E A ADESÃO DA TURMA?"</a:t>
-            </a:r>
-          </a:p>
-          <a:p>
-            <a:r>
-              <a:t>"Ela saiu do modelo. Antes a gente calculava turma vezes taxa de adesão, o que</a:t>
-            </a:r>
-          </a:p>
-          <a:p>
-            <a:r>
-              <a:t>exigia saber o tamanho da turma. Agora contamos aluno captado direto. Menos</a:t>
-            </a:r>
-          </a:p>
-          <a:p>
-            <a:r>
-              <a:t>premissa, menos coisa para errar."</a:t>
+              <a:t>A nossa meta para o primeiro ano é captar 100 alunos, somando todas as turmas e instituições parceiras. Cada aluno cursará doze módulos ao longo de vinte meses. O modelo financeiro apoia-se em duas fontes: uma taxa por módulo de cem reais paga voluntariamente pelo aluno por encontro cursado, e uma comissão paga pelos fornecedores que começa em 3% e evolui até 6,4%. Para as escolas, o custo é zero, pois elas entram apenas com o CNPJ, as turmas e o calendário. O ponto central aqui é que a unidade de negócio passa a ser o aluno captado de forma individual, eliminando de vez a fragilidade de depender do tamanho fechado de uma turma ou da adesão interna dela.</a:t>
             </a:r>
           </a:p>
         </p:txBody>
@@ -1154,139 +792,7 @@
           <a:lstStyle/>
           <a:p>
             <a:r>
-              <a:t>[ 90 segundos — este é o slide mais importante da apresentação ]</a:t>
-            </a:r>
-          </a:p>
-          <a:p/>
-          <a:p>
-            <a:r>
-              <a:t>O GANCHO — comece pela pergunta do título</a:t>
-            </a:r>
-          </a:p>
-          <a:p>
-            <a:r>
-              <a:t>"Por que uma companhia aérea venderia mais barato para a Antévia do que vende</a:t>
-            </a:r>
-          </a:p>
-          <a:p>
-            <a:r>
-              <a:t>direto para o aluno? No primeiro ano, com uma ou duas instituições, ela não</a:t>
-            </a:r>
-          </a:p>
-          <a:p>
-            <a:r>
-              <a:t>venderia. E a nossa primeira versão deste modelo assumia que sim."</a:t>
-            </a:r>
-          </a:p>
-          <a:p/>
-          <a:p>
-            <a:r>
-              <a:t>AS TRÊS FASES — percorra a tabela</a:t>
-            </a:r>
-          </a:p>
-          <a:p>
-            <a:r>
-              <a:t>"Ano 1: compramos apoiados numa consolidadora parceira, uma agência B2B que já</a:t>
-            </a:r>
-          </a:p>
-          <a:p>
-            <a:r>
-              <a:t>tem convênio e volume. Recebemos repasse de parte da comissão dela. 3%."</a:t>
-            </a:r>
-          </a:p>
-          <a:p>
-            <a:r>
-              <a:t>"Ano 2: com volume, negociamos bloqueios pontuais nas rotas que concentram. 5%."</a:t>
-            </a:r>
-          </a:p>
-          <a:p>
-            <a:r>
-              <a:t>"Ano 3: convênio próprio. 6,4%."</a:t>
-            </a:r>
-          </a:p>
-          <a:p/>
-          <a:p>
-            <a:r>
-              <a:t>O CARD DA ESQUERDA — a mensagem central</a:t>
-            </a:r>
-          </a:p>
-          <a:p>
-            <a:r>
-              <a:t>"O que sustenta o ano 1 é uma alavanca que não custa nada: antecipação. Comprar</a:t>
-            </a:r>
-          </a:p>
-          <a:p>
-            <a:r>
-              <a:t>aos 90 dias em vez de em cima da hora já é mais barato na curva tarifária</a:t>
-            </a:r>
-          </a:p>
-          <a:p>
-            <a:r>
-              <a:t>pública. Não precisamos negociar com ninguém para ter isso."</a:t>
-            </a:r>
-          </a:p>
-          <a:p/>
-          <a:p>
-            <a:r>
-              <a:t>SE PERGUNTAREM: "DE ONDE VÊM ESSES PERCENTUAIS DE COMISSÃO?"</a:t>
-            </a:r>
-          </a:p>
-          <a:p>
-            <a:r>
-              <a:t>Pergunta muito provável. Resposta em duas camadas:</a:t>
-            </a:r>
-          </a:p>
-          <a:p/>
-          <a:p>
-            <a:r>
-              <a:t>1) A FONTE: "Da entrevista com o Bruno Brant, sócio da Velt, na Sprint 1. Ele</a:t>
-            </a:r>
-          </a:p>
-          <a:p>
-            <a:r>
-              <a:t>   deu as faixas praticadas: um convênio de R$ 250 a 500 mil por ano rende de 3</a:t>
-            </a:r>
-          </a:p>
-          <a:p>
-            <a:r>
-              <a:t>   a 5%; acima de R$ 1 milhão por ano, de 8 a 12%."</a:t>
-            </a:r>
-          </a:p>
-          <a:p/>
-          <a:p>
-            <a:r>
-              <a:t>2) O TESTE: "Nós conferimos o nosso próprio volume contra essas faixas. No ano 1</a:t>
-            </a:r>
-          </a:p>
-          <a:p>
-            <a:r>
-              <a:t>   movimentamos R$ 518 mil em aéreo — exatamente na entrada da primeira faixa,</a:t>
-            </a:r>
-          </a:p>
-          <a:p>
-            <a:r>
-              <a:t>   o que sustenta os 3%. Nos anos 2 e 3 passamos de R$ 1 milhão, o que abriria</a:t>
-            </a:r>
-          </a:p>
-          <a:p>
-            <a:r>
-              <a:t>   8 a 12% — e mesmo assim usamos 5% e 6,4%. Fomos deliberadamente conservadores."</a:t>
-            </a:r>
-          </a:p>
-          <a:p/>
-          <a:p>
-            <a:r>
-              <a:t>3) A COMPOSIÇÃO DOS 6,4%: "É uma média ponderada. Aéreo remunera pouco, cerca de</a:t>
-            </a:r>
-          </a:p>
-          <a:p>
-            <a:r>
-              <a:t>   4%; hotelaria remunera bem, uns 10%; traslado 10%. Aplicado ao nosso ticket,</a:t>
-            </a:r>
-          </a:p>
-          <a:p>
-            <a:r>
-              <a:t>   dá R$ 108,80 por viagem, que são 6,4% do valor transacionado."</a:t>
+              <a:t>O poder de negociação no setor é conquistado, e não assumido de início. No primeiro ano, ainda não temos escala para forçar tarifas diferenciadas diretamente com as companhias aéreas. Nossa alavanca inicial não exige negociar com fornecedores: trata-se puramente da antecipação de compra aos noventa dias em vez de em cima da hora, utilizando a curva tarifária pública de forma gratuita. Com isso, já entregamos 180 reais de economia líquida por viagem e garantimos 3% de comissão. Nos anos seguintes, com os bloqueios de rotas e convênios próprios, essa economia por viagem sobe para 300 e 400 reais, acompanhando o crescimento das nossas comissões para 5% e 6,4%, patamares totalmente conservadores frente aos volumes previstos com parceiros como a Velt.</a:t>
             </a:r>
           </a:p>
         </p:txBody>
@@ -1356,134 +862,7 @@
           <a:lstStyle/>
           <a:p>
             <a:r>
-              <a:t>[ 75 segundos ]</a:t>
-            </a:r>
-          </a:p>
-          <a:p/>
-          <a:p>
-            <a:r>
-              <a:t>CONTEXTO — explique o problema antes de mostrar a tabela</a:t>
-            </a:r>
-          </a:p>
-          <a:p>
-            <a:r>
-              <a:t>"Tarifa de grupo não é um desconto que se pede. É um produto que só existe quando</a:t>
-            </a:r>
-          </a:p>
-          <a:p>
-            <a:r>
-              <a:t>há passageiros suficientes no mesmo voo — o mercado trabalha com cerca de 10</a:t>
-            </a:r>
-          </a:p>
-          <a:p>
-            <a:r>
-              <a:t>pessoas na mesma rota."</a:t>
-            </a:r>
-          </a:p>
-          <a:p/>
-          <a:p>
-            <a:r>
-              <a:t>"A pergunta então é: quantos alunos nós conseguimos juntar no mesmo campus, na</a:t>
-            </a:r>
-          </a:p>
-          <a:p>
-            <a:r>
-              <a:t>mesma data de módulo?"</a:t>
-            </a:r>
-          </a:p>
-          <a:p/>
-          <a:p>
-            <a:r>
-              <a:t>COMO LER A TABELA — vá linha a linha, devagar</a:t>
-            </a:r>
-          </a:p>
-          <a:p>
-            <a:r>
-              <a:t>"Cada linha é uma quantidade de alunos concentrados. As colunas são o número de</a:t>
-            </a:r>
-          </a:p>
-          <a:p>
-            <a:r>
-              <a:t>cidades de origem deles — quanto mais espalhados, menos gente por rota."</a:t>
-            </a:r>
-          </a:p>
-          <a:p/>
-          <a:p>
-            <a:r>
-              <a:t>"Com 100 alunos e 6 origens: 100 dividido por 6 dá quase 17 passageiros por rota.</a:t>
-            </a:r>
-          </a:p>
-          <a:p>
-            <a:r>
-              <a:t>Forma grupo."</a:t>
-            </a:r>
-          </a:p>
-          <a:p>
-            <a:r>
-              <a:t>"Com 50 alunos: 8 por rota. Não forma, a não ser que sejam só 5 origens."</a:t>
-            </a:r>
-          </a:p>
-          <a:p>
-            <a:r>
-              <a:t>"E a última linha é a que importa: uma turma de 40 alunos, com metade viajando,</a:t>
-            </a:r>
-          </a:p>
-          <a:p>
-            <a:r>
-              <a:t>dá 3 passageiros por rota. Nenhuma turma sozinha forma grupo."</a:t>
-            </a:r>
-          </a:p>
-          <a:p/>
-          <a:p>
-            <a:r>
-              <a:t>A CONCLUSÃO — é o ponto do slide</a:t>
-            </a:r>
-          </a:p>
-          <a:p>
-            <a:r>
-              <a:t>"Por isso a unidade de negociação não pode ser a turma. Tem que ser o campus numa</a:t>
-            </a:r>
-          </a:p>
-          <a:p>
-            <a:r>
-              <a:t>data, somando alunos de turmas diferentes que chegam no mesmo dia."</a:t>
-            </a:r>
-          </a:p>
-          <a:p/>
-          <a:p>
-            <a:r>
-              <a:t>"E isso é bom para nós: se quem junta o volume é a plataforma, o bloqueio é nosso</a:t>
-            </a:r>
-          </a:p>
-          <a:p>
-            <a:r>
-              <a:t>ativo, não da escola."</a:t>
-            </a:r>
-          </a:p>
-          <a:p/>
-          <a:p>
-            <a:r>
-              <a:t>SE PERGUNTAREM: "ENTÃO VOCÊS NÃO TÊM TARIFA DE GRUPO NO ANO 1?"</a:t>
-            </a:r>
-          </a:p>
-          <a:p>
-            <a:r>
-              <a:t>"Temos, se concentrarmos. O limiar é 50 a 60 alunos numa mesma data. A meta de</a:t>
-            </a:r>
-          </a:p>
-          <a:p>
-            <a:r>
-              <a:t>100 alunos passa disso — desde que a captação seja concentrada e não pulverizada</a:t>
-            </a:r>
-          </a:p>
-          <a:p>
-            <a:r>
-              <a:t>entre vários campi. É por isso que a métrica do ano 1 não é só quantos alunos,</a:t>
-            </a:r>
-          </a:p>
-          <a:p>
-            <a:r>
-              <a:t>é onde eles estão."</a:t>
+              <a:t>Uma tarifa corporativa de grupo exige em torno de dez passageiros na mesma rota e data. Como nenhuma turma isolada consegue formar esse volume sozinha, a nossa estratégia consiste na concentração: somar alunos de várias turmas diferentes no mesmo campus e na mesma data. Quando atingimos o limiar de cinquenta a sessenta alunos por data, destravamos a tarifa de grupo. Como quem agrega e gerencia esse volume é a nossa plataforma, o poder de bloqueio e o ativo passam a ser da Antévia.</a:t>
             </a:r>
           </a:p>
         </p:txBody>
@@ -1553,97 +932,7 @@
           <a:lstStyle/>
           <a:p>
             <a:r>
-              <a:t>[ 55 segundos ]</a:t>
-            </a:r>
-          </a:p>
-          <a:p/>
-          <a:p>
-            <a:r>
-              <a:t>O QUE FALAR</a:t>
-            </a:r>
-          </a:p>
-          <a:p>
-            <a:r>
-              <a:t>"Hoje o aluno de fora gasta R$ 2.200 por módulo comprando em cima da hora. Aqui</a:t>
-            </a:r>
-          </a:p>
-          <a:p>
-            <a:r>
-              <a:t>está o que ele passa a gastar com a Antévia, em cada fase."</a:t>
-            </a:r>
-          </a:p>
-          <a:p/>
-          <a:p>
-            <a:r>
-              <a:t>"No ano 1: R$ 1.920 de logística, mais R$ 100 da nossa taxa. Ele economiza R$ 180</a:t>
-            </a:r>
-          </a:p>
-          <a:p>
-            <a:r>
-              <a:t>líquidos."</a:t>
-            </a:r>
-          </a:p>
-          <a:p>
-            <a:r>
-              <a:t>"No ano 3, com convênio próprio: economiza R$ 400."</a:t>
-            </a:r>
-          </a:p>
-          <a:p/>
-          <a:p>
-            <a:r>
-              <a:t>SEJA HONESTO COM A LINHA DE BAIXO — é o que dá credibilidade</a:t>
-            </a:r>
-          </a:p>
-          <a:p>
-            <a:r>
-              <a:t>"Reparem na última linha. A redução no desembolso é de 8,2% no primeiro ano e</a:t>
-            </a:r>
-          </a:p>
-          <a:p>
-            <a:r>
-              <a:t>chega a 18,2% no terceiro."</a:t>
-            </a:r>
-          </a:p>
-          <a:p/>
-          <a:p>
-            <a:r>
-              <a:t>"A meta que fixamos na Sprint 1 era de 15 a 25% de redução. Nós só entregamos</a:t>
-            </a:r>
-          </a:p>
-          <a:p>
-            <a:r>
-              <a:t>isso na fase 3. Preferimos mostrar assim do que prometer o número cheio desde o</a:t>
-            </a:r>
-          </a:p>
-          <a:p>
-            <a:r>
-              <a:t>começo."</a:t>
-            </a:r>
-          </a:p>
-          <a:p/>
-          <a:p>
-            <a:r>
-              <a:t>SE PERGUNTAREM: "MAS VOCÊS NÃO DIZIAM 20 A 30% NA BANCA?"</a:t>
-            </a:r>
-          </a:p>
-          <a:p>
-            <a:r>
-              <a:t>"Dizíamos, e continua verdade — mas é o desconto do bloqueio de grupo sobre a</a:t>
-            </a:r>
-          </a:p>
-          <a:p>
-            <a:r>
-              <a:t>logística, na operação madura. Quando a gente desconta a nossa taxa e olha o que</a:t>
-            </a:r>
-          </a:p>
-          <a:p>
-            <a:r>
-              <a:t>sai do bolso do aluno no primeiro ano, é 8,2%. São medidas diferentes e agora</a:t>
-            </a:r>
-          </a:p>
-          <a:p>
-            <a:r>
-              <a:t>estão separadas."</a:t>
+              <a:t>Analisando a economia por módulo fase a fase, vemos que hoje um aluno avulso desembolsa em média 2.200 reais comprando passagens e hospedagens em cima da hora. Na fase um, com a nossa antecedência e a taxa de serviço de cem reais, o subtotal logístico cai para 1.920 reais, gerando uma economia líquida de 180 reais para o aluno, o que representa uma redução de 8,2% no desembolso. Essa economia evolui para 13,6% na fase dois e atinge de 15% a 25% na fase três. O ponto comercial importante é que, no primeiro ano, o aluno não compra apenas pelo desconto financeiro, mas principalmente pela conveniência de não precisar orquestrar três plataformas diferentes a cada módulo.</a:t>
             </a:r>
           </a:p>
         </p:txBody>
@@ -1713,70 +1002,7 @@
           <a:lstStyle/>
           <a:p>
             <a:r>
-              <a:t>[ 50 segundos ]</a:t>
-            </a:r>
-          </a:p>
-          <a:p/>
-          <a:p>
-            <a:r>
-              <a:t>O QUE FALAR</a:t>
-            </a:r>
-          </a:p>
-          <a:p>
-            <a:r>
-              <a:t>"Antes de definir preço, olhamos como o mercado cobra hoje. Cinco alternativas,</a:t>
-            </a:r>
-          </a:p>
-          <a:p>
-            <a:r>
-              <a:t>nenhuma resolve a operação inteira de um programa."</a:t>
-            </a:r>
-          </a:p>
-          <a:p/>
-          <a:p>
-            <a:r>
-              <a:t>"Apps de companhia: taxa zero, mas resolvem um trecho e não conhecem o calendário."</a:t>
-            </a:r>
-          </a:p>
-          <a:p>
-            <a:r>
-              <a:t>"OTAs: cobram de zero a R$ 80 por emissão, mas é viagem a viagem."</a:t>
-            </a:r>
-          </a:p>
-          <a:p>
-            <a:r>
-              <a:t>"Agência tradicional: R$ 40 a 120 por bilhete, cotação reativa."</a:t>
-            </a:r>
-          </a:p>
-          <a:p>
-            <a:r>
-              <a:t>"Plataformas B2B como Onfly e Argo: exigem CNPJ. O aluno pessoa física fica de</a:t>
-            </a:r>
-          </a:p>
-          <a:p>
-            <a:r>
-              <a:t>fora — é o nosso 'órfão estrutural' da Sprint 1."</a:t>
-            </a:r>
-          </a:p>
-          <a:p>
-            <a:r>
-              <a:t>"Concierge premium: 5 a 15% da viagem, mas não existe recorte para aluno-executivo."</a:t>
-            </a:r>
-          </a:p>
-          <a:p/>
-          <a:p>
-            <a:r>
-              <a:t>A FRASE DE FECHO — leia a faixa dourada, é o achado</a:t>
-            </a:r>
-          </a:p>
-          <a:p>
-            <a:r>
-              <a:t>"O custo real da decisão tardia é invisível para o aluno. Ele não paga uma taxa</a:t>
-            </a:r>
-          </a:p>
-          <a:p>
-            <a:r>
-              <a:t>alta: ele paga uma passagem cara. E por isso não percebe que está perdendo."</a:t>
+              <a:t>O mercado atual cobra por alternativas que não resolvem a operação inteira de um programa executivo. Aplicativos diretos das companhias oferecem passagens sem taxa mas ignoram o calendário acadêmico; OTAs como Decolar e CVC focam em conveniência individual sem integração; agências tradicionais cobram taxas altas por bilhete com cotação reativa; plataformas B2B exigem CNPJ e deixam o aluno pessoa física de fora; e concierges premium cobram de 5% a 15% do valor da viagem. O custo real da decisão tardia hoje é invisível para o aluno: ele não aparece como taxa, mas sim no preço abusivo da passagem comprada de última hora.</a:t>
             </a:r>
           </a:p>
         </p:txBody>
@@ -1846,97 +1072,7 @@
           <a:lstStyle/>
           <a:p>
             <a:r>
-              <a:t>[ 55 segundos ]</a:t>
-            </a:r>
-          </a:p>
-          <a:p/>
-          <a:p>
-            <a:r>
-              <a:t>O QUE FALAR</a:t>
-            </a:r>
-          </a:p>
-          <a:p>
-            <a:r>
-              <a:t>"Nós não perguntamos ao aluno quanto ele pagaria. Ancoramos o preço no que o</a:t>
-            </a:r>
-          </a:p>
-          <a:p>
-            <a:r>
-              <a:t>serviço devolve para ele."</a:t>
-            </a:r>
-          </a:p>
-          <a:p/>
-          <a:p>
-            <a:r>
-              <a:t>"No ano 1 ele paga R$ 100 e recebe R$ 180 — retorno de 1,8 vez."</a:t>
-            </a:r>
-          </a:p>
-          <a:p>
-            <a:r>
-              <a:t>"No ano 3, R$ 100 viram R$ 400 — retorno de 4 vezes."</a:t>
-            </a:r>
-          </a:p>
-          <a:p/>
-          <a:p>
-            <a:r>
-              <a:t>O CARD DA DIREITA — explique o que ele significa</a:t>
-            </a:r>
-          </a:p>
-          <a:p>
-            <a:r>
-              <a:t>"E a dependência do bolso do aluno cai: no ano 1, 63% da nossa receita vem da</a:t>
-            </a:r>
-          </a:p>
-          <a:p>
-            <a:r>
-              <a:t>taxa; no ano 3, 48%. Conforme a comissão cresce, ficamos menos expostos à</a:t>
-            </a:r>
-          </a:p>
-          <a:p>
-            <a:r>
-              <a:t>disposição a pagar dele."</a:t>
-            </a:r>
-          </a:p>
-          <a:p/>
-          <a:p>
-            <a:r>
-              <a:t>A CONSEQUÊNCIA COMERCIAL — leia a faixa escura</a:t>
-            </a:r>
-          </a:p>
-          <a:p>
-            <a:r>
-              <a:t>"O que isso quer dizer na prática: no primeiro ano a venda não se sustenta só no</a:t>
-            </a:r>
-          </a:p>
-          <a:p>
-            <a:r>
-              <a:t>desconto, porque a folga é apertada. Ela se sustenta no tempo devolvido e em não</a:t>
-            </a:r>
-          </a:p>
-          <a:p>
-            <a:r>
-              <a:t>ter que orquestrar três plataformas por módulo."</a:t>
-            </a:r>
-          </a:p>
-          <a:p/>
-          <a:p>
-            <a:r>
-              <a:t>SE PERGUNTAREM SOBRE A H6</a:t>
-            </a:r>
-          </a:p>
-          <a:p>
-            <a:r>
-              <a:t>"A hipótese de que o aluno pagaria de R$ 50 a 150 continua a validar. Os R$ 100</a:t>
-            </a:r>
-          </a:p>
-          <a:p>
-            <a:r>
-              <a:t>são o meio da faixa. Se cair para R$ 50, o modelo perde um quarto da receita —</a:t>
-            </a:r>
-          </a:p>
-          <a:p>
-            <a:r>
-              <a:t>fica menor, não deixa de existir."</a:t>
+              <a:t>A nossa taxa de cem reais foi ancorada no valor real entregue ao aluno, e não em uma disposição arbitrária de pagamento. No primeiro ano, o aluno paga cem reais de taxa e recebe 180 reais líquidos de economia, o que representa um retorno de 1,8 vez. Conforme avançamos para as fases dois e três, esse retorno sobe para 3,0 e 4,0 vezes o valor investido, enquanto o peso da taxa no bolso do aluno cai de 63% para 48%. Isso demonstra que a dependência do bolso do participante diminui à medida que a receita de comissão dos fornecedores ganha robustez.</a:t>
             </a:r>
           </a:p>
         </p:txBody>
@@ -2006,139 +1142,7 @@
           <a:lstStyle/>
           <a:p>
             <a:r>
-              <a:t>[ 75 segundos — vá devagar, é o slide que mais gera dúvida ]</a:t>
-            </a:r>
-          </a:p>
-          <a:p/>
-          <a:p>
-            <a:r>
-              <a:t>EXPLIQUE A LÓGICA DO FUNIL ANTES DOS NÚMEROS</a:t>
-            </a:r>
-          </a:p>
-          <a:p>
-            <a:r>
-              <a:t>"Três recortes de mercado, do maior para o menor."</a:t>
-            </a:r>
-          </a:p>
-          <a:p/>
-          <a:p>
-            <a:r>
-              <a:t>TAM — a faixa de cima</a:t>
-            </a:r>
-          </a:p>
-          <a:p>
-            <a:r>
-              <a:t>"TAM é o mercado total: todo aluno de programa executivo no Brasil que precisa</a:t>
-            </a:r>
-          </a:p>
-          <a:p>
-            <a:r>
-              <a:t>viajar para estudar. Chegamos a 42 mil pessoas, partindo do dado do IBGE de 1,4</a:t>
-            </a:r>
-          </a:p>
-          <a:p>
-            <a:r>
-              <a:t>milhão de matriculados em pós-graduação, filtrando os que estão em programas</a:t>
-            </a:r>
-          </a:p>
-          <a:p>
-            <a:r>
-              <a:t>executivos presenciais e os que viajam de outra cidade."</a:t>
-            </a:r>
-          </a:p>
-          <a:p>
-            <a:r>
-              <a:t>"Se atendêssemos todos, seriam R$ 63 milhões por ano."</a:t>
-            </a:r>
-          </a:p>
-          <a:p/>
-          <a:p>
-            <a:r>
-              <a:t>SAM — a faixa do meio</a:t>
-            </a:r>
-          </a:p>
-          <a:p>
-            <a:r>
-              <a:t>"SAM é o mercado que dá para atender de fato. A Sprint 1 mostrou que a dor se</a:t>
-            </a:r>
-          </a:p>
-          <a:p>
-            <a:r>
-              <a:t>concentra nos campi que recebem aluno de fora — Nova Lima, São Paulo e Rio.</a:t>
-            </a:r>
-          </a:p>
-          <a:p>
-            <a:r>
-              <a:t>Restringindo a isso, são 10.500 alunos e R$ 15,8 milhões por ano."</a:t>
-            </a:r>
-          </a:p>
-          <a:p/>
-          <a:p>
-            <a:r>
-              <a:t>SOM — a faixa de baixo</a:t>
-            </a:r>
-          </a:p>
-          <a:p>
-            <a:r>
-              <a:t>"SOM é o que pretendemos capturar em três anos: 650 alunos ativos, R$ 977 mil de</a:t>
-            </a:r>
-          </a:p>
-          <a:p>
-            <a:r>
-              <a:t>receita anualizada, 6,2% do SAM."</a:t>
-            </a:r>
-          </a:p>
-          <a:p/>
-          <a:p>
-            <a:r>
-              <a:t>CUIDADO COM UM MAL-ENTENDIDO</a:t>
-            </a:r>
-          </a:p>
-          <a:p>
-            <a:r>
-              <a:t>Deixe explícito: "Os 650 são alunos ATIVOS no último trimestre — não é a soma dos</a:t>
-            </a:r>
-          </a:p>
-          <a:p>
-            <a:r>
-              <a:t>três anos. É a base de clientes que a operação tem funcionando ao fim do ano 3."</a:t>
-            </a:r>
-          </a:p>
-          <a:p/>
-          <a:p>
-            <a:r>
-              <a:t>A TABELA DE BAIXO</a:t>
-            </a:r>
-          </a:p>
-          <a:p>
-            <a:r>
-              <a:t>"E aqui a progressão: 100 alunos no ano 1, que é 1% do SAM. 280 no ano 2. 650 no</a:t>
-            </a:r>
-          </a:p>
-          <a:p>
-            <a:r>
-              <a:t>ano 3."</a:t>
-            </a:r>
-          </a:p>
-          <a:p/>
-          <a:p>
-            <a:r>
-              <a:t>SE PERGUNTAREM: "6,2% NÃO É POUCO?"</a:t>
-            </a:r>
-          </a:p>
-          <a:p>
-            <a:r>
-              <a:t>"É pouco e é proposital. A primeira versão da nossa projeção dizia 24% do SAM em</a:t>
-            </a:r>
-          </a:p>
-          <a:p>
-            <a:r>
-              <a:t>três anos, o que não se defende para um negócio que capta aluno por aluno, pelo</a:t>
-            </a:r>
-          </a:p>
-          <a:p>
-            <a:r>
-              <a:t>canal da escola. Preferimos um número que a gente consiga sustentar."</a:t>
+              <a:t>Nosso potencial de mercado foi construído de baixo para cima utilizando a base de dados do IBGE. O TAM totaliza 42.000 alunos-viajantes, representando um mercado potencial de 63,1 milhões de reais por ano. O SAM restrito aos polos de Nova Lima, São Paulo e Rio de Janeiro alcança 10.500 alunos e 15,8 milhões de reais. O nosso SOM projeta 650 alunos ativos no décimo segundo trimestre, o que representa 977 mil de receita anualizada, ou 6,2% do SAM. Partimos de 100 alunos ativos no primeiro ano para 280 no segundo, ajustando projeções anteriores que eram irreais.</a:t>
             </a:r>
           </a:p>
         </p:txBody>
@@ -2208,107 +1212,7 @@
           <a:lstStyle/>
           <a:p>
             <a:r>
-              <a:t>[ 70 segundos ]</a:t>
-            </a:r>
-          </a:p>
-          <a:p/>
-          <a:p>
-            <a:r>
-              <a:t>O QUE FALAR</a:t>
-            </a:r>
-          </a:p>
-          <a:p>
-            <a:r>
-              <a:t>"Três cenários. O que separa um do outro é uma coisa só: quantos alunos a</a:t>
-            </a:r>
-          </a:p>
-          <a:p>
-            <a:r>
-              <a:t>operação capta. As fases de negociação são as mesmas nos três."</a:t>
-            </a:r>
-          </a:p>
-          <a:p/>
-          <a:p>
-            <a:r>
-              <a:t>"Pessimista: 50 alunos no ano 1, R$ 551 mil em três anos."</a:t>
-            </a:r>
-          </a:p>
-          <a:p>
-            <a:r>
-              <a:t>"Tendencial: 100 alunos no ano 1, R$ 1,10 milhão."</a:t>
-            </a:r>
-          </a:p>
-          <a:p>
-            <a:r>
-              <a:t>"Otimista: 160 alunos no ano 1, R$ 1,83 milhão."</a:t>
-            </a:r>
-          </a:p>
-          <a:p/>
-          <a:p>
-            <a:r>
-              <a:t>A TABELA — aponte a linha do meio</a:t>
-            </a:r>
-          </a:p>
-          <a:p>
-            <a:r>
-              <a:t>"Na linha do tendencial: R$ 71 mil no ano 1, R$ 284 mil no ano 2, R$ 744 mil no</a:t>
-            </a:r>
-          </a:p>
-          <a:p>
-            <a:r>
-              <a:t>ano 3. A curva é bem inclinada porque tanto o número de alunos quanto a comissão</a:t>
-            </a:r>
-          </a:p>
-          <a:p>
-            <a:r>
-              <a:t>crescem juntos."</a:t>
-            </a:r>
-          </a:p>
-          <a:p/>
-          <a:p>
-            <a:r>
-              <a:t>A FAIXA DOURADA — não pule, é o melhor argumento de venda</a:t>
-            </a:r>
-          </a:p>
-          <a:p>
-            <a:r>
-              <a:t>"E reparem na última coluna: R$ 1,95 milhão de economia devolvida aos alunos,</a:t>
-            </a:r>
-          </a:p>
-          <a:p>
-            <a:r>
-              <a:t>quase o dobro da nossa receita. Esse é o número que faz a escola querer indicar</a:t>
-            </a:r>
-          </a:p>
-          <a:p>
-            <a:r>
-              <a:t>o serviço — é dinheiro que deixa de sair do bolso dos alunos dela."</a:t>
-            </a:r>
-          </a:p>
-          <a:p/>
-          <a:p>
-            <a:r>
-              <a:t>SE PERGUNTAREM POR MARGEM OU LUCRO</a:t>
-            </a:r>
-          </a:p>
-          <a:p>
-            <a:r>
-              <a:t>"Esta sprint é de receita. E vale registrar: nós não compramos e revendemos</a:t>
-            </a:r>
-          </a:p>
-          <a:p>
-            <a:r>
-              <a:t>passagem. O aluno paga o fornecedor direto, nós intermediamos. Então não há custo</a:t>
-            </a:r>
-          </a:p>
-          <a:p>
-            <a:r>
-              <a:t>de mercadoria vendida aqui — todos os nossos custos são operacionais, e eles</a:t>
-            </a:r>
-          </a:p>
-          <a:p>
-            <a:r>
-              <a:t>entram na Sprint 5."</a:t>
+              <a:t>Trabalhamos com três cenários de receita ao longo de três anos. No cenário pessimista, captamos 50 alunos no ano um, totalizando 551 mil de receita em três anos. No cenário tendencial, que é a nossa diretriz, captamos 100 alunos no ano um, atingindo 650 alunos ativos no término do ciclo e gerando 1,10 milhão de reais em receita. No cenário otimista, alcançamos 1,83 milhão de reais. Em todos os cenários, vale destacar que o volume financeiro devolvido como economia direta aos alunos é praticamente o dobro da receita total acumulada pela empresa.</a:t>
             </a:r>
           </a:p>
         </p:txBody>

</xml_diff>

<commit_message>
Slide 8: TAM, SAM e SOM viram perguntas em portugues
O grupo apontou que as siglas exigem explicacao no meio da apresentacao.
As faixas do funil passam a ter rotulo em linguagem direta, com a sigla
mantida em tamanho menor a direita para quem conhece o framework:

  Quantos existem      (TAM)  - 42.000 alunos-viajantes no Brasil
  Quantos podemos atender (SAM) - 10.500 alunos em Nova Lima, SP e Rio
  Quantos vamos atender  (SOM)  - 650 alunos ativos, nossa meta em 3 anos

A coluna da tabela deixa de ser % do SAM e passa a % dos 10.500, que nomeia
o denominador de forma autoexplicativa.

Tambem alinhado: a fala do slide 8 nas anotacoes, os titulos das secoes em
oferta-e-mercado.md, e as mencoes a SAM nos READMEs e em cenarios-de-receita.

Corrige de passagem uma linha do README que ainda citava 30% de adesao, do
modelo por turma que saiu na versao anterior.

Co-Authored-By: Claude Opus 5 <noreply@anthropic.com>
</commit_message>
<xml_diff>
--- a/sprints/sprint-04/entregaveis/Sprint_04_Kairos_Antevia.pptx
+++ b/sprints/sprint-04/entregaveis/Sprint_04_Kairos_Antevia.pptx
@@ -1142,7 +1142,7 @@
           <a:lstStyle/>
           <a:p>
             <a:r>
-              <a:t>Nosso potencial de mercado foi construído de baixo para cima utilizando a base de dados do IBGE. O TAM totaliza 42.000 alunos-viajantes, representando um mercado potencial de 63,1 milhões de reais por ano. O SAM restrito aos polos de Nova Lima, São Paulo e Rio de Janeiro alcança 10.500 alunos e 15,8 milhões de reais. O nosso SOM projeta 650 alunos ativos no décimo segundo trimestre, o que representa 977 mil de receita anualizada, ou 6,2% do SAM. Partimos de 100 alunos ativos no primeiro ano para 280 no segundo, ajustando projeções anteriores que eram irreais.</a:t>
+              <a:t>Nosso potencial de mercado foi construído de baixo para cima utilizando a base de dados do IBGE. Quantos existem: no Brasil inteiro são 42.000 alunos-viajantes, um mercado potencial de 63,1 milhões de reais por ano. Quantos podemos atender: restringindo aos polos de Nova Lima, São Paulo e Rio de Janeiro, são 10.500 alunos e 15,8 milhões de reais. E quantos vamos atender: a nossa meta é chegar a 650 alunos ativos no décimo segundo trimestre, o que representa 977 mil de receita anualizada, ou 6,2% desses 10.500. Partimos de 100 alunos ativos no primeiro ano para 280 no segundo, ajustando projeções anteriores que eram irreais.</a:t>
             </a:r>
           </a:p>
         </p:txBody>
@@ -15081,8 +15081,8 @@
         </p:nvSpPr>
         <p:spPr>
           <a:xfrm>
-            <a:off x="320040" y="1965960"/>
-            <a:ext cx="11521440" cy="841248"/>
+            <a:off x="320040" y="1938528"/>
+            <a:ext cx="11521440" cy="896112"/>
           </a:xfrm>
           <a:prstGeom prst="roundRect">
             <a:avLst>
@@ -15125,8 +15125,8 @@
         </p:nvSpPr>
         <p:spPr>
           <a:xfrm>
-            <a:off x="594359" y="2075688"/>
-            <a:ext cx="1280160" cy="320040"/>
+            <a:off x="576072" y="2066544"/>
+            <a:ext cx="2834640" cy="274320"/>
           </a:xfrm>
           <a:prstGeom prst="rect">
             <a:avLst/>
@@ -15141,12 +15141,152 @@
           <a:p>
             <a:pPr algn="l"/>
             <a:r>
-              <a:rPr sz="1900" b="1">
+              <a:rPr sz="1550" b="1">
                 <a:solidFill>
                   <a:srgbClr val="0B1220"/>
                 </a:solidFill>
                 <a:latin typeface="Sora"/>
               </a:rPr>
+              <a:t>Quantos existem</a:t>
+            </a:r>
+          </a:p>
+        </p:txBody>
+      </p:sp>
+      <p:sp>
+        <p:nvSpPr>
+          <p:cNvPr id="6" name="TextBox 5"/>
+          <p:cNvSpPr txBox="1"/>
+          <p:nvPr/>
+        </p:nvSpPr>
+        <p:spPr>
+          <a:xfrm>
+            <a:off x="576072" y="2432304"/>
+            <a:ext cx="2834640" cy="237744"/>
+          </a:xfrm>
+          <a:prstGeom prst="rect">
+            <a:avLst/>
+          </a:prstGeom>
+          <a:noFill/>
+        </p:spPr>
+        <p:txBody>
+          <a:bodyPr wrap="square" lIns="0" rIns="0" tIns="0" bIns="0">
+            <a:spAutoFit/>
+          </a:bodyPr>
+          <a:lstStyle/>
+          <a:p>
+            <a:pPr algn="l"/>
+            <a:r>
+              <a:rPr sz="1000" b="0">
+                <a:solidFill>
+                  <a:srgbClr val="0B1220"/>
+                </a:solidFill>
+                <a:latin typeface="Inter"/>
+              </a:rPr>
+              <a:t>no Brasil inteiro</a:t>
+            </a:r>
+          </a:p>
+        </p:txBody>
+      </p:sp>
+      <p:sp>
+        <p:nvSpPr>
+          <p:cNvPr id="7" name="TextBox 6"/>
+          <p:cNvSpPr txBox="1"/>
+          <p:nvPr/>
+        </p:nvSpPr>
+        <p:spPr>
+          <a:xfrm>
+            <a:off x="3566160" y="2084832"/>
+            <a:ext cx="7223759" cy="274320"/>
+          </a:xfrm>
+          <a:prstGeom prst="rect">
+            <a:avLst/>
+          </a:prstGeom>
+          <a:noFill/>
+        </p:spPr>
+        <p:txBody>
+          <a:bodyPr wrap="square" lIns="0" rIns="0" tIns="0" bIns="0">
+            <a:spAutoFit/>
+          </a:bodyPr>
+          <a:lstStyle/>
+          <a:p>
+            <a:pPr algn="l"/>
+            <a:r>
+              <a:rPr sz="1350" b="1">
+                <a:solidFill>
+                  <a:srgbClr val="0B1220"/>
+                </a:solidFill>
+                <a:latin typeface="Inter SemiBold"/>
+              </a:rPr>
+              <a:t>42.000 alunos-viajantes</a:t>
+            </a:r>
+          </a:p>
+        </p:txBody>
+      </p:sp>
+      <p:sp>
+        <p:nvSpPr>
+          <p:cNvPr id="8" name="TextBox 7"/>
+          <p:cNvSpPr txBox="1"/>
+          <p:nvPr/>
+        </p:nvSpPr>
+        <p:spPr>
+          <a:xfrm>
+            <a:off x="3566160" y="2441448"/>
+            <a:ext cx="7223759" cy="256032"/>
+          </a:xfrm>
+          <a:prstGeom prst="rect">
+            <a:avLst/>
+          </a:prstGeom>
+          <a:noFill/>
+        </p:spPr>
+        <p:txBody>
+          <a:bodyPr wrap="square" lIns="0" rIns="0" tIns="0" bIns="0">
+            <a:spAutoFit/>
+          </a:bodyPr>
+          <a:lstStyle/>
+          <a:p>
+            <a:pPr algn="l"/>
+            <a:r>
+              <a:rPr sz="1100" b="0">
+                <a:solidFill>
+                  <a:srgbClr val="0B1220"/>
+                </a:solidFill>
+                <a:latin typeface="Inter"/>
+              </a:rPr>
+              <a:t>R$ 63,1 mi por ano</a:t>
+            </a:r>
+          </a:p>
+        </p:txBody>
+      </p:sp>
+      <p:sp>
+        <p:nvSpPr>
+          <p:cNvPr id="9" name="TextBox 8"/>
+          <p:cNvSpPr txBox="1"/>
+          <p:nvPr/>
+        </p:nvSpPr>
+        <p:spPr>
+          <a:xfrm>
+            <a:off x="11018519" y="2267712"/>
+            <a:ext cx="566928" cy="237744"/>
+          </a:xfrm>
+          <a:prstGeom prst="rect">
+            <a:avLst/>
+          </a:prstGeom>
+          <a:noFill/>
+        </p:spPr>
+        <p:txBody>
+          <a:bodyPr wrap="square" lIns="0" rIns="0" tIns="0" bIns="0">
+            <a:spAutoFit/>
+          </a:bodyPr>
+          <a:lstStyle/>
+          <a:p>
+            <a:pPr algn="r"/>
+            <a:r>
+              <a:rPr sz="1000" b="1" spc="140">
+                <a:solidFill>
+                  <a:srgbClr val="0B1220"/>
+                </a:solidFill>
+                <a:latin typeface="Inter SemiBold"/>
+              </a:rPr>
               <a:t>TAM</a:t>
             </a:r>
           </a:p>
@@ -15154,84 +15294,14 @@
       </p:sp>
       <p:sp>
         <p:nvSpPr>
-          <p:cNvPr id="6" name="TextBox 5"/>
-          <p:cNvSpPr txBox="1"/>
-          <p:nvPr/>
-        </p:nvSpPr>
-        <p:spPr>
-          <a:xfrm>
-            <a:off x="1965960" y="2075688"/>
-            <a:ext cx="9601200" cy="274320"/>
-          </a:xfrm>
-          <a:prstGeom prst="rect">
-            <a:avLst/>
-          </a:prstGeom>
-          <a:noFill/>
-        </p:spPr>
-        <p:txBody>
-          <a:bodyPr wrap="square" lIns="0" rIns="0" tIns="0" bIns="0">
-            <a:spAutoFit/>
-          </a:bodyPr>
-          <a:lstStyle/>
-          <a:p>
-            <a:pPr algn="l"/>
-            <a:r>
-              <a:rPr sz="1300" b="1">
-                <a:solidFill>
-                  <a:srgbClr val="0B1220"/>
-                </a:solidFill>
-                <a:latin typeface="Inter SemiBold"/>
-              </a:rPr>
-              <a:t>42.000 alunos-viajantes</a:t>
-            </a:r>
-          </a:p>
-        </p:txBody>
-      </p:sp>
-      <p:sp>
-        <p:nvSpPr>
-          <p:cNvPr id="7" name="TextBox 6"/>
-          <p:cNvSpPr txBox="1"/>
-          <p:nvPr/>
-        </p:nvSpPr>
-        <p:spPr>
-          <a:xfrm>
-            <a:off x="1965960" y="2404872"/>
-            <a:ext cx="9601200" cy="274320"/>
-          </a:xfrm>
-          <a:prstGeom prst="rect">
-            <a:avLst/>
-          </a:prstGeom>
-          <a:noFill/>
-        </p:spPr>
-        <p:txBody>
-          <a:bodyPr wrap="square" lIns="0" rIns="0" tIns="0" bIns="0">
-            <a:spAutoFit/>
-          </a:bodyPr>
-          <a:lstStyle/>
-          <a:p>
-            <a:pPr algn="l"/>
-            <a:r>
-              <a:rPr sz="1000" b="0">
-                <a:solidFill>
-                  <a:srgbClr val="0B1220"/>
-                </a:solidFill>
-                <a:latin typeface="Inter"/>
-              </a:rPr>
-              <a:t>R$ 63,1 mi/ano — mercado de um operador maduro</a:t>
-            </a:r>
-          </a:p>
-        </p:txBody>
-      </p:sp>
-      <p:sp>
-        <p:nvSpPr>
-          <p:cNvPr id="8" name="Rounded Rectangle 7"/>
+          <p:cNvPr id="10" name="Rounded Rectangle 9"/>
           <p:cNvSpPr/>
           <p:nvPr/>
         </p:nvSpPr>
         <p:spPr>
           <a:xfrm>
-            <a:off x="2057399" y="2926080"/>
-            <a:ext cx="8046720" cy="841248"/>
+            <a:off x="1828799" y="2944368"/>
+            <a:ext cx="8503920" cy="896112"/>
           </a:xfrm>
           <a:prstGeom prst="roundRect">
             <a:avLst>
@@ -15268,14 +15338,14 @@
       </p:sp>
       <p:sp>
         <p:nvSpPr>
-          <p:cNvPr id="9" name="TextBox 8"/>
-          <p:cNvSpPr txBox="1"/>
-          <p:nvPr/>
-        </p:nvSpPr>
-        <p:spPr>
-          <a:xfrm>
-            <a:off x="2331719" y="3035808"/>
-            <a:ext cx="1280160" cy="320040"/>
+          <p:cNvPr id="11" name="TextBox 10"/>
+          <p:cNvSpPr txBox="1"/>
+          <p:nvPr/>
+        </p:nvSpPr>
+        <p:spPr>
+          <a:xfrm>
+            <a:off x="2084831" y="3072384"/>
+            <a:ext cx="2834640" cy="274320"/>
           </a:xfrm>
           <a:prstGeom prst="rect">
             <a:avLst/>
@@ -15290,12 +15360,152 @@
           <a:p>
             <a:pPr algn="l"/>
             <a:r>
-              <a:rPr sz="1900" b="1">
+              <a:rPr sz="1550" b="1">
                 <a:solidFill>
                   <a:srgbClr val="0B1220"/>
                 </a:solidFill>
                 <a:latin typeface="Sora"/>
               </a:rPr>
+              <a:t>Quantos podemos atender</a:t>
+            </a:r>
+          </a:p>
+        </p:txBody>
+      </p:sp>
+      <p:sp>
+        <p:nvSpPr>
+          <p:cNvPr id="12" name="TextBox 11"/>
+          <p:cNvSpPr txBox="1"/>
+          <p:nvPr/>
+        </p:nvSpPr>
+        <p:spPr>
+          <a:xfrm>
+            <a:off x="2084831" y="3438144"/>
+            <a:ext cx="2834640" cy="237744"/>
+          </a:xfrm>
+          <a:prstGeom prst="rect">
+            <a:avLst/>
+          </a:prstGeom>
+          <a:noFill/>
+        </p:spPr>
+        <p:txBody>
+          <a:bodyPr wrap="square" lIns="0" rIns="0" tIns="0" bIns="0">
+            <a:spAutoFit/>
+          </a:bodyPr>
+          <a:lstStyle/>
+          <a:p>
+            <a:pPr algn="l"/>
+            <a:r>
+              <a:rPr sz="1000" b="0">
+                <a:solidFill>
+                  <a:srgbClr val="0B1220"/>
+                </a:solidFill>
+                <a:latin typeface="Inter"/>
+              </a:rPr>
+              <a:t>Nova Lima, São Paulo e Rio</a:t>
+            </a:r>
+          </a:p>
+        </p:txBody>
+      </p:sp>
+      <p:sp>
+        <p:nvSpPr>
+          <p:cNvPr id="13" name="TextBox 12"/>
+          <p:cNvSpPr txBox="1"/>
+          <p:nvPr/>
+        </p:nvSpPr>
+        <p:spPr>
+          <a:xfrm>
+            <a:off x="5074919" y="3090672"/>
+            <a:ext cx="4206240" cy="274320"/>
+          </a:xfrm>
+          <a:prstGeom prst="rect">
+            <a:avLst/>
+          </a:prstGeom>
+          <a:noFill/>
+        </p:spPr>
+        <p:txBody>
+          <a:bodyPr wrap="square" lIns="0" rIns="0" tIns="0" bIns="0">
+            <a:spAutoFit/>
+          </a:bodyPr>
+          <a:lstStyle/>
+          <a:p>
+            <a:pPr algn="l"/>
+            <a:r>
+              <a:rPr sz="1350" b="1">
+                <a:solidFill>
+                  <a:srgbClr val="0B1220"/>
+                </a:solidFill>
+                <a:latin typeface="Inter SemiBold"/>
+              </a:rPr>
+              <a:t>10.500 alunos</a:t>
+            </a:r>
+          </a:p>
+        </p:txBody>
+      </p:sp>
+      <p:sp>
+        <p:nvSpPr>
+          <p:cNvPr id="14" name="TextBox 13"/>
+          <p:cNvSpPr txBox="1"/>
+          <p:nvPr/>
+        </p:nvSpPr>
+        <p:spPr>
+          <a:xfrm>
+            <a:off x="5074919" y="3447288"/>
+            <a:ext cx="4206240" cy="256032"/>
+          </a:xfrm>
+          <a:prstGeom prst="rect">
+            <a:avLst/>
+          </a:prstGeom>
+          <a:noFill/>
+        </p:spPr>
+        <p:txBody>
+          <a:bodyPr wrap="square" lIns="0" rIns="0" tIns="0" bIns="0">
+            <a:spAutoFit/>
+          </a:bodyPr>
+          <a:lstStyle/>
+          <a:p>
+            <a:pPr algn="l"/>
+            <a:r>
+              <a:rPr sz="1100" b="0">
+                <a:solidFill>
+                  <a:srgbClr val="0B1220"/>
+                </a:solidFill>
+                <a:latin typeface="Inter"/>
+              </a:rPr>
+              <a:t>R$ 15,8 mi por ano</a:t>
+            </a:r>
+          </a:p>
+        </p:txBody>
+      </p:sp>
+      <p:sp>
+        <p:nvSpPr>
+          <p:cNvPr id="15" name="TextBox 14"/>
+          <p:cNvSpPr txBox="1"/>
+          <p:nvPr/>
+        </p:nvSpPr>
+        <p:spPr>
+          <a:xfrm>
+            <a:off x="9509760" y="3273552"/>
+            <a:ext cx="566928" cy="237744"/>
+          </a:xfrm>
+          <a:prstGeom prst="rect">
+            <a:avLst/>
+          </a:prstGeom>
+          <a:noFill/>
+        </p:spPr>
+        <p:txBody>
+          <a:bodyPr wrap="square" lIns="0" rIns="0" tIns="0" bIns="0">
+            <a:spAutoFit/>
+          </a:bodyPr>
+          <a:lstStyle/>
+          <a:p>
+            <a:pPr algn="r"/>
+            <a:r>
+              <a:rPr sz="1000" b="1" spc="140">
+                <a:solidFill>
+                  <a:srgbClr val="0B1220"/>
+                </a:solidFill>
+                <a:latin typeface="Inter SemiBold"/>
+              </a:rPr>
               <a:t>SAM</a:t>
             </a:r>
           </a:p>
@@ -15303,84 +15513,14 @@
       </p:sp>
       <p:sp>
         <p:nvSpPr>
-          <p:cNvPr id="10" name="TextBox 9"/>
-          <p:cNvSpPr txBox="1"/>
-          <p:nvPr/>
-        </p:nvSpPr>
-        <p:spPr>
-          <a:xfrm>
-            <a:off x="3703320" y="3035808"/>
-            <a:ext cx="6126480" cy="274320"/>
-          </a:xfrm>
-          <a:prstGeom prst="rect">
-            <a:avLst/>
-          </a:prstGeom>
-          <a:noFill/>
-        </p:spPr>
-        <p:txBody>
-          <a:bodyPr wrap="square" lIns="0" rIns="0" tIns="0" bIns="0">
-            <a:spAutoFit/>
-          </a:bodyPr>
-          <a:lstStyle/>
-          <a:p>
-            <a:pPr algn="l"/>
-            <a:r>
-              <a:rPr sz="1300" b="1">
-                <a:solidFill>
-                  <a:srgbClr val="0B1220"/>
-                </a:solidFill>
-                <a:latin typeface="Inter SemiBold"/>
-              </a:rPr>
-              <a:t>10.500 alunos · Nova Lima, SP e Rio</a:t>
-            </a:r>
-          </a:p>
-        </p:txBody>
-      </p:sp>
-      <p:sp>
-        <p:nvSpPr>
-          <p:cNvPr id="11" name="TextBox 10"/>
-          <p:cNvSpPr txBox="1"/>
-          <p:nvPr/>
-        </p:nvSpPr>
-        <p:spPr>
-          <a:xfrm>
-            <a:off x="3703320" y="3364992"/>
-            <a:ext cx="6126480" cy="274320"/>
-          </a:xfrm>
-          <a:prstGeom prst="rect">
-            <a:avLst/>
-          </a:prstGeom>
-          <a:noFill/>
-        </p:spPr>
-        <p:txBody>
-          <a:bodyPr wrap="square" lIns="0" rIns="0" tIns="0" bIns="0">
-            <a:spAutoFit/>
-          </a:bodyPr>
-          <a:lstStyle/>
-          <a:p>
-            <a:pPr algn="l"/>
-            <a:r>
-              <a:rPr sz="1000" b="0">
-                <a:solidFill>
-                  <a:srgbClr val="0B1220"/>
-                </a:solidFill>
-                <a:latin typeface="Inter"/>
-              </a:rPr>
-              <a:t>R$ 15,8 mi/ano</a:t>
-            </a:r>
-          </a:p>
-        </p:txBody>
-      </p:sp>
-      <p:sp>
-        <p:nvSpPr>
-          <p:cNvPr id="12" name="Rounded Rectangle 11"/>
+          <p:cNvPr id="16" name="Rounded Rectangle 15"/>
           <p:cNvSpPr/>
           <p:nvPr/>
         </p:nvSpPr>
         <p:spPr>
           <a:xfrm>
-            <a:off x="3703320" y="3886200"/>
-            <a:ext cx="4754880" cy="841248"/>
+            <a:off x="2857500" y="3950208"/>
+            <a:ext cx="6446520" cy="896112"/>
           </a:xfrm>
           <a:prstGeom prst="roundRect">
             <a:avLst>
@@ -15417,14 +15557,14 @@
       </p:sp>
       <p:sp>
         <p:nvSpPr>
-          <p:cNvPr id="13" name="TextBox 12"/>
-          <p:cNvSpPr txBox="1"/>
-          <p:nvPr/>
-        </p:nvSpPr>
-        <p:spPr>
-          <a:xfrm>
-            <a:off x="3977639" y="3995928"/>
-            <a:ext cx="1280160" cy="320040"/>
+          <p:cNvPr id="17" name="TextBox 16"/>
+          <p:cNvSpPr txBox="1"/>
+          <p:nvPr/>
+        </p:nvSpPr>
+        <p:spPr>
+          <a:xfrm>
+            <a:off x="3113532" y="4078224"/>
+            <a:ext cx="2834640" cy="274320"/>
           </a:xfrm>
           <a:prstGeom prst="rect">
             <a:avLst/>
@@ -15439,12 +15579,152 @@
           <a:p>
             <a:pPr algn="l"/>
             <a:r>
-              <a:rPr sz="1900" b="1">
+              <a:rPr sz="1550" b="1">
                 <a:solidFill>
                   <a:srgbClr val="0B1220"/>
                 </a:solidFill>
                 <a:latin typeface="Sora"/>
               </a:rPr>
+              <a:t>Quantos vamos atender</a:t>
+            </a:r>
+          </a:p>
+        </p:txBody>
+      </p:sp>
+      <p:sp>
+        <p:nvSpPr>
+          <p:cNvPr id="18" name="TextBox 17"/>
+          <p:cNvSpPr txBox="1"/>
+          <p:nvPr/>
+        </p:nvSpPr>
+        <p:spPr>
+          <a:xfrm>
+            <a:off x="3113532" y="4443984"/>
+            <a:ext cx="2834640" cy="237744"/>
+          </a:xfrm>
+          <a:prstGeom prst="rect">
+            <a:avLst/>
+          </a:prstGeom>
+          <a:noFill/>
+        </p:spPr>
+        <p:txBody>
+          <a:bodyPr wrap="square" lIns="0" rIns="0" tIns="0" bIns="0">
+            <a:spAutoFit/>
+          </a:bodyPr>
+          <a:lstStyle/>
+          <a:p>
+            <a:pPr algn="l"/>
+            <a:r>
+              <a:rPr sz="1000" b="0">
+                <a:solidFill>
+                  <a:srgbClr val="0B1220"/>
+                </a:solidFill>
+                <a:latin typeface="Inter"/>
+              </a:rPr>
+              <a:t>nossa meta em 3 anos</a:t>
+            </a:r>
+          </a:p>
+        </p:txBody>
+      </p:sp>
+      <p:sp>
+        <p:nvSpPr>
+          <p:cNvPr id="19" name="TextBox 18"/>
+          <p:cNvSpPr txBox="1"/>
+          <p:nvPr/>
+        </p:nvSpPr>
+        <p:spPr>
+          <a:xfrm>
+            <a:off x="6103620" y="4096512"/>
+            <a:ext cx="2148839" cy="274320"/>
+          </a:xfrm>
+          <a:prstGeom prst="rect">
+            <a:avLst/>
+          </a:prstGeom>
+          <a:noFill/>
+        </p:spPr>
+        <p:txBody>
+          <a:bodyPr wrap="square" lIns="0" rIns="0" tIns="0" bIns="0">
+            <a:spAutoFit/>
+          </a:bodyPr>
+          <a:lstStyle/>
+          <a:p>
+            <a:pPr algn="l"/>
+            <a:r>
+              <a:rPr sz="1350" b="1">
+                <a:solidFill>
+                  <a:srgbClr val="0B1220"/>
+                </a:solidFill>
+                <a:latin typeface="Inter SemiBold"/>
+              </a:rPr>
+              <a:t>650 alunos ativos</a:t>
+            </a:r>
+          </a:p>
+        </p:txBody>
+      </p:sp>
+      <p:sp>
+        <p:nvSpPr>
+          <p:cNvPr id="20" name="TextBox 19"/>
+          <p:cNvSpPr txBox="1"/>
+          <p:nvPr/>
+        </p:nvSpPr>
+        <p:spPr>
+          <a:xfrm>
+            <a:off x="6103620" y="4453128"/>
+            <a:ext cx="2148839" cy="256032"/>
+          </a:xfrm>
+          <a:prstGeom prst="rect">
+            <a:avLst/>
+          </a:prstGeom>
+          <a:noFill/>
+        </p:spPr>
+        <p:txBody>
+          <a:bodyPr wrap="square" lIns="0" rIns="0" tIns="0" bIns="0">
+            <a:spAutoFit/>
+          </a:bodyPr>
+          <a:lstStyle/>
+          <a:p>
+            <a:pPr algn="l"/>
+            <a:r>
+              <a:rPr sz="1100" b="0">
+                <a:solidFill>
+                  <a:srgbClr val="0B1220"/>
+                </a:solidFill>
+                <a:latin typeface="Inter"/>
+              </a:rPr>
+              <a:t>R$ 977 mil por ano</a:t>
+            </a:r>
+          </a:p>
+        </p:txBody>
+      </p:sp>
+      <p:sp>
+        <p:nvSpPr>
+          <p:cNvPr id="21" name="TextBox 20"/>
+          <p:cNvSpPr txBox="1"/>
+          <p:nvPr/>
+        </p:nvSpPr>
+        <p:spPr>
+          <a:xfrm>
+            <a:off x="8481060" y="4279392"/>
+            <a:ext cx="566928" cy="237744"/>
+          </a:xfrm>
+          <a:prstGeom prst="rect">
+            <a:avLst/>
+          </a:prstGeom>
+          <a:noFill/>
+        </p:spPr>
+        <p:txBody>
+          <a:bodyPr wrap="square" lIns="0" rIns="0" tIns="0" bIns="0">
+            <a:spAutoFit/>
+          </a:bodyPr>
+          <a:lstStyle/>
+          <a:p>
+            <a:pPr algn="r"/>
+            <a:r>
+              <a:rPr sz="1000" b="1" spc="140">
+                <a:solidFill>
+                  <a:srgbClr val="0B1220"/>
+                </a:solidFill>
+                <a:latin typeface="Inter SemiBold"/>
+              </a:rPr>
               <a:t>SOM</a:t>
             </a:r>
           </a:p>
@@ -15452,83 +15732,13 @@
       </p:sp>
       <p:sp>
         <p:nvSpPr>
-          <p:cNvPr id="14" name="TextBox 13"/>
-          <p:cNvSpPr txBox="1"/>
-          <p:nvPr/>
-        </p:nvSpPr>
-        <p:spPr>
-          <a:xfrm>
-            <a:off x="5349240" y="3995928"/>
-            <a:ext cx="2834640" cy="274320"/>
-          </a:xfrm>
-          <a:prstGeom prst="rect">
-            <a:avLst/>
-          </a:prstGeom>
-          <a:noFill/>
-        </p:spPr>
-        <p:txBody>
-          <a:bodyPr wrap="square" lIns="0" rIns="0" tIns="0" bIns="0">
-            <a:spAutoFit/>
-          </a:bodyPr>
-          <a:lstStyle/>
-          <a:p>
-            <a:pPr algn="l"/>
-            <a:r>
-              <a:rPr sz="1300" b="1">
-                <a:solidFill>
-                  <a:srgbClr val="0B1220"/>
-                </a:solidFill>
-                <a:latin typeface="Inter SemiBold"/>
-              </a:rPr>
-              <a:t>650 alunos ativos no T12</a:t>
-            </a:r>
-          </a:p>
-        </p:txBody>
-      </p:sp>
-      <p:sp>
-        <p:nvSpPr>
-          <p:cNvPr id="15" name="TextBox 14"/>
-          <p:cNvSpPr txBox="1"/>
-          <p:nvPr/>
-        </p:nvSpPr>
-        <p:spPr>
-          <a:xfrm>
-            <a:off x="5349240" y="4325112"/>
-            <a:ext cx="2834640" cy="274320"/>
-          </a:xfrm>
-          <a:prstGeom prst="rect">
-            <a:avLst/>
-          </a:prstGeom>
-          <a:noFill/>
-        </p:spPr>
-        <p:txBody>
-          <a:bodyPr wrap="square" lIns="0" rIns="0" tIns="0" bIns="0">
-            <a:spAutoFit/>
-          </a:bodyPr>
-          <a:lstStyle/>
-          <a:p>
-            <a:pPr algn="l"/>
-            <a:r>
-              <a:rPr sz="1000" b="0">
-                <a:solidFill>
-                  <a:srgbClr val="0B1220"/>
-                </a:solidFill>
-                <a:latin typeface="Inter"/>
-              </a:rPr>
-              <a:t>R$ 977 mil/ano · 6,2% do SAM</a:t>
-            </a:r>
-          </a:p>
-        </p:txBody>
-      </p:sp>
-      <p:sp>
-        <p:nvSpPr>
-          <p:cNvPr id="16" name="Rectangle 15"/>
+          <p:cNvPr id="22" name="Rectangle 21"/>
           <p:cNvSpPr/>
           <p:nvPr/>
         </p:nvSpPr>
         <p:spPr>
           <a:xfrm>
-            <a:off x="320040" y="4983480"/>
+            <a:off x="320040" y="5010912"/>
             <a:ext cx="11521440" cy="292608"/>
           </a:xfrm>
           <a:prstGeom prst="rect">
@@ -15564,13 +15774,13 @@
       </p:sp>
       <p:sp>
         <p:nvSpPr>
-          <p:cNvPr id="17" name="TextBox 16"/>
-          <p:cNvSpPr txBox="1"/>
-          <p:nvPr/>
-        </p:nvSpPr>
-        <p:spPr>
-          <a:xfrm>
-            <a:off x="429768" y="5074920"/>
+          <p:cNvPr id="23" name="TextBox 22"/>
+          <p:cNvSpPr txBox="1"/>
+          <p:nvPr/>
+        </p:nvSpPr>
+        <p:spPr>
+          <a:xfrm>
+            <a:off x="429768" y="5102352"/>
             <a:ext cx="2660904" cy="201168"/>
           </a:xfrm>
           <a:prstGeom prst="rect">
@@ -15599,13 +15809,13 @@
       </p:sp>
       <p:sp>
         <p:nvSpPr>
-          <p:cNvPr id="18" name="TextBox 17"/>
-          <p:cNvSpPr txBox="1"/>
-          <p:nvPr/>
-        </p:nvSpPr>
-        <p:spPr>
-          <a:xfrm>
-            <a:off x="3310128" y="5074920"/>
+          <p:cNvPr id="24" name="TextBox 23"/>
+          <p:cNvSpPr txBox="1"/>
+          <p:nvPr/>
+        </p:nvSpPr>
+        <p:spPr>
+          <a:xfrm>
+            <a:off x="3310128" y="5102352"/>
             <a:ext cx="2660904" cy="201168"/>
           </a:xfrm>
           <a:prstGeom prst="rect">
@@ -15634,13 +15844,13 @@
       </p:sp>
       <p:sp>
         <p:nvSpPr>
-          <p:cNvPr id="19" name="TextBox 18"/>
-          <p:cNvSpPr txBox="1"/>
-          <p:nvPr/>
-        </p:nvSpPr>
-        <p:spPr>
-          <a:xfrm>
-            <a:off x="6190488" y="5074920"/>
+          <p:cNvPr id="25" name="TextBox 24"/>
+          <p:cNvSpPr txBox="1"/>
+          <p:nvPr/>
+        </p:nvSpPr>
+        <p:spPr>
+          <a:xfrm>
+            <a:off x="6190488" y="5102352"/>
             <a:ext cx="2660904" cy="201168"/>
           </a:xfrm>
           <a:prstGeom prst="rect">
@@ -15669,13 +15879,13 @@
       </p:sp>
       <p:sp>
         <p:nvSpPr>
-          <p:cNvPr id="20" name="TextBox 19"/>
-          <p:cNvSpPr txBox="1"/>
-          <p:nvPr/>
-        </p:nvSpPr>
-        <p:spPr>
-          <a:xfrm>
-            <a:off x="9070848" y="5074920"/>
+          <p:cNvPr id="26" name="TextBox 25"/>
+          <p:cNvSpPr txBox="1"/>
+          <p:nvPr/>
+        </p:nvSpPr>
+        <p:spPr>
+          <a:xfrm>
+            <a:off x="9070848" y="5102352"/>
             <a:ext cx="2660904" cy="201168"/>
           </a:xfrm>
           <a:prstGeom prst="rect">
@@ -15697,20 +15907,20 @@
                 </a:solidFill>
                 <a:latin typeface="Inter SemiBold"/>
               </a:rPr>
-              <a:t>% do SAM</a:t>
-            </a:r>
-          </a:p>
-        </p:txBody>
-      </p:sp>
-      <p:sp>
-        <p:nvSpPr>
-          <p:cNvPr id="21" name="Rectangle 20"/>
+              <a:t>% dos 10.500</a:t>
+            </a:r>
+          </a:p>
+        </p:txBody>
+      </p:sp>
+      <p:sp>
+        <p:nvSpPr>
+          <p:cNvPr id="27" name="Rectangle 26"/>
           <p:cNvSpPr/>
           <p:nvPr/>
         </p:nvSpPr>
         <p:spPr>
           <a:xfrm>
-            <a:off x="320040" y="5276088"/>
+            <a:off x="320040" y="5303520"/>
             <a:ext cx="11521440" cy="310896"/>
           </a:xfrm>
           <a:prstGeom prst="rect">
@@ -15748,13 +15958,13 @@
       </p:sp>
       <p:sp>
         <p:nvSpPr>
-          <p:cNvPr id="22" name="TextBox 21"/>
-          <p:cNvSpPr txBox="1"/>
-          <p:nvPr/>
-        </p:nvSpPr>
-        <p:spPr>
-          <a:xfrm>
-            <a:off x="429768" y="5376672"/>
+          <p:cNvPr id="28" name="TextBox 27"/>
+          <p:cNvSpPr txBox="1"/>
+          <p:nvPr/>
+        </p:nvSpPr>
+        <p:spPr>
+          <a:xfrm>
+            <a:off x="429768" y="5404104"/>
             <a:ext cx="2660904" cy="164592"/>
           </a:xfrm>
           <a:prstGeom prst="rect">
@@ -15783,13 +15993,13 @@
       </p:sp>
       <p:sp>
         <p:nvSpPr>
-          <p:cNvPr id="23" name="TextBox 22"/>
-          <p:cNvSpPr txBox="1"/>
-          <p:nvPr/>
-        </p:nvSpPr>
-        <p:spPr>
-          <a:xfrm>
-            <a:off x="3310128" y="5376672"/>
+          <p:cNvPr id="29" name="TextBox 28"/>
+          <p:cNvSpPr txBox="1"/>
+          <p:nvPr/>
+        </p:nvSpPr>
+        <p:spPr>
+          <a:xfrm>
+            <a:off x="3310128" y="5404104"/>
             <a:ext cx="2660904" cy="164592"/>
           </a:xfrm>
           <a:prstGeom prst="rect">
@@ -15818,13 +16028,13 @@
       </p:sp>
       <p:sp>
         <p:nvSpPr>
-          <p:cNvPr id="24" name="TextBox 23"/>
-          <p:cNvSpPr txBox="1"/>
-          <p:nvPr/>
-        </p:nvSpPr>
-        <p:spPr>
-          <a:xfrm>
-            <a:off x="6190488" y="5376672"/>
+          <p:cNvPr id="30" name="TextBox 29"/>
+          <p:cNvSpPr txBox="1"/>
+          <p:nvPr/>
+        </p:nvSpPr>
+        <p:spPr>
+          <a:xfrm>
+            <a:off x="6190488" y="5404104"/>
             <a:ext cx="2660904" cy="164592"/>
           </a:xfrm>
           <a:prstGeom prst="rect">
@@ -15853,13 +16063,13 @@
       </p:sp>
       <p:sp>
         <p:nvSpPr>
-          <p:cNvPr id="25" name="TextBox 24"/>
-          <p:cNvSpPr txBox="1"/>
-          <p:nvPr/>
-        </p:nvSpPr>
-        <p:spPr>
-          <a:xfrm>
-            <a:off x="9070848" y="5376672"/>
+          <p:cNvPr id="31" name="TextBox 30"/>
+          <p:cNvSpPr txBox="1"/>
+          <p:nvPr/>
+        </p:nvSpPr>
+        <p:spPr>
+          <a:xfrm>
+            <a:off x="9070848" y="5404104"/>
             <a:ext cx="2660904" cy="164592"/>
           </a:xfrm>
           <a:prstGeom prst="rect">
@@ -15888,13 +16098,13 @@
       </p:sp>
       <p:sp>
         <p:nvSpPr>
-          <p:cNvPr id="26" name="Rectangle 25"/>
+          <p:cNvPr id="32" name="Rectangle 31"/>
           <p:cNvSpPr/>
           <p:nvPr/>
         </p:nvSpPr>
         <p:spPr>
           <a:xfrm>
-            <a:off x="320040" y="5586984"/>
+            <a:off x="320040" y="5614416"/>
             <a:ext cx="11521440" cy="310896"/>
           </a:xfrm>
           <a:prstGeom prst="rect">
@@ -15932,13 +16142,13 @@
       </p:sp>
       <p:sp>
         <p:nvSpPr>
-          <p:cNvPr id="27" name="TextBox 26"/>
-          <p:cNvSpPr txBox="1"/>
-          <p:nvPr/>
-        </p:nvSpPr>
-        <p:spPr>
-          <a:xfrm>
-            <a:off x="429768" y="5687568"/>
+          <p:cNvPr id="33" name="TextBox 32"/>
+          <p:cNvSpPr txBox="1"/>
+          <p:nvPr/>
+        </p:nvSpPr>
+        <p:spPr>
+          <a:xfrm>
+            <a:off x="429768" y="5715000"/>
             <a:ext cx="2660904" cy="164592"/>
           </a:xfrm>
           <a:prstGeom prst="rect">
@@ -15967,13 +16177,13 @@
       </p:sp>
       <p:sp>
         <p:nvSpPr>
-          <p:cNvPr id="28" name="TextBox 27"/>
-          <p:cNvSpPr txBox="1"/>
-          <p:nvPr/>
-        </p:nvSpPr>
-        <p:spPr>
-          <a:xfrm>
-            <a:off x="3310128" y="5687568"/>
+          <p:cNvPr id="34" name="TextBox 33"/>
+          <p:cNvSpPr txBox="1"/>
+          <p:nvPr/>
+        </p:nvSpPr>
+        <p:spPr>
+          <a:xfrm>
+            <a:off x="3310128" y="5715000"/>
             <a:ext cx="2660904" cy="164592"/>
           </a:xfrm>
           <a:prstGeom prst="rect">
@@ -16002,13 +16212,13 @@
       </p:sp>
       <p:sp>
         <p:nvSpPr>
-          <p:cNvPr id="29" name="TextBox 28"/>
-          <p:cNvSpPr txBox="1"/>
-          <p:nvPr/>
-        </p:nvSpPr>
-        <p:spPr>
-          <a:xfrm>
-            <a:off x="6190488" y="5687568"/>
+          <p:cNvPr id="35" name="TextBox 34"/>
+          <p:cNvSpPr txBox="1"/>
+          <p:nvPr/>
+        </p:nvSpPr>
+        <p:spPr>
+          <a:xfrm>
+            <a:off x="6190488" y="5715000"/>
             <a:ext cx="2660904" cy="164592"/>
           </a:xfrm>
           <a:prstGeom prst="rect">
@@ -16037,13 +16247,13 @@
       </p:sp>
       <p:sp>
         <p:nvSpPr>
-          <p:cNvPr id="30" name="TextBox 29"/>
-          <p:cNvSpPr txBox="1"/>
-          <p:nvPr/>
-        </p:nvSpPr>
-        <p:spPr>
-          <a:xfrm>
-            <a:off x="9070848" y="5687568"/>
+          <p:cNvPr id="36" name="TextBox 35"/>
+          <p:cNvSpPr txBox="1"/>
+          <p:nvPr/>
+        </p:nvSpPr>
+        <p:spPr>
+          <a:xfrm>
+            <a:off x="9070848" y="5715000"/>
             <a:ext cx="2660904" cy="164592"/>
           </a:xfrm>
           <a:prstGeom prst="rect">
@@ -16072,13 +16282,13 @@
       </p:sp>
       <p:sp>
         <p:nvSpPr>
-          <p:cNvPr id="31" name="Rectangle 30"/>
+          <p:cNvPr id="37" name="Rectangle 36"/>
           <p:cNvSpPr/>
           <p:nvPr/>
         </p:nvSpPr>
         <p:spPr>
           <a:xfrm>
-            <a:off x="320040" y="5897880"/>
+            <a:off x="320040" y="5925312"/>
             <a:ext cx="11521440" cy="310896"/>
           </a:xfrm>
           <a:prstGeom prst="rect">
@@ -16116,13 +16326,13 @@
       </p:sp>
       <p:sp>
         <p:nvSpPr>
-          <p:cNvPr id="32" name="TextBox 31"/>
-          <p:cNvSpPr txBox="1"/>
-          <p:nvPr/>
-        </p:nvSpPr>
-        <p:spPr>
-          <a:xfrm>
-            <a:off x="429768" y="5998464"/>
+          <p:cNvPr id="38" name="TextBox 37"/>
+          <p:cNvSpPr txBox="1"/>
+          <p:nvPr/>
+        </p:nvSpPr>
+        <p:spPr>
+          <a:xfrm>
+            <a:off x="429768" y="6025896"/>
             <a:ext cx="2660904" cy="164592"/>
           </a:xfrm>
           <a:prstGeom prst="rect">
@@ -16151,13 +16361,13 @@
       </p:sp>
       <p:sp>
         <p:nvSpPr>
-          <p:cNvPr id="33" name="TextBox 32"/>
-          <p:cNvSpPr txBox="1"/>
-          <p:nvPr/>
-        </p:nvSpPr>
-        <p:spPr>
-          <a:xfrm>
-            <a:off x="3310128" y="5998464"/>
+          <p:cNvPr id="39" name="TextBox 38"/>
+          <p:cNvSpPr txBox="1"/>
+          <p:nvPr/>
+        </p:nvSpPr>
+        <p:spPr>
+          <a:xfrm>
+            <a:off x="3310128" y="6025896"/>
             <a:ext cx="2660904" cy="164592"/>
           </a:xfrm>
           <a:prstGeom prst="rect">
@@ -16186,13 +16396,13 @@
       </p:sp>
       <p:sp>
         <p:nvSpPr>
-          <p:cNvPr id="34" name="TextBox 33"/>
-          <p:cNvSpPr txBox="1"/>
-          <p:nvPr/>
-        </p:nvSpPr>
-        <p:spPr>
-          <a:xfrm>
-            <a:off x="6190488" y="5998464"/>
+          <p:cNvPr id="40" name="TextBox 39"/>
+          <p:cNvSpPr txBox="1"/>
+          <p:nvPr/>
+        </p:nvSpPr>
+        <p:spPr>
+          <a:xfrm>
+            <a:off x="6190488" y="6025896"/>
             <a:ext cx="2660904" cy="164592"/>
           </a:xfrm>
           <a:prstGeom prst="rect">
@@ -16221,13 +16431,13 @@
       </p:sp>
       <p:sp>
         <p:nvSpPr>
-          <p:cNvPr id="35" name="TextBox 34"/>
-          <p:cNvSpPr txBox="1"/>
-          <p:nvPr/>
-        </p:nvSpPr>
-        <p:spPr>
-          <a:xfrm>
-            <a:off x="9070848" y="5998464"/>
+          <p:cNvPr id="41" name="TextBox 40"/>
+          <p:cNvSpPr txBox="1"/>
+          <p:nvPr/>
+        </p:nvSpPr>
+        <p:spPr>
+          <a:xfrm>
+            <a:off x="9070848" y="6025896"/>
             <a:ext cx="2660904" cy="164592"/>
           </a:xfrm>
           <a:prstGeom prst="rect">
@@ -16256,13 +16466,13 @@
       </p:sp>
       <p:sp>
         <p:nvSpPr>
-          <p:cNvPr id="36" name="TextBox 35"/>
-          <p:cNvSpPr txBox="1"/>
-          <p:nvPr/>
-        </p:nvSpPr>
-        <p:spPr>
-          <a:xfrm>
-            <a:off x="320040" y="6327648"/>
+          <p:cNvPr id="42" name="TextBox 41"/>
+          <p:cNvSpPr txBox="1"/>
+          <p:nvPr/>
+        </p:nvSpPr>
+        <p:spPr>
+          <a:xfrm>
+            <a:off x="320040" y="6364224"/>
             <a:ext cx="11521440" cy="228600"/>
           </a:xfrm>
           <a:prstGeom prst="rect">
@@ -16284,14 +16494,14 @@
                 </a:solidFill>
                 <a:latin typeface="Inter"/>
               </a:rPr>
-              <a:t>A primeira versão projetava 24% do SAM, assumindo turma de 100 alunos e adesão de 60% desde o T1. Não se sustentava.</a:t>
-            </a:r>
-          </a:p>
-        </p:txBody>
-      </p:sp>
-      <p:sp>
-        <p:nvSpPr>
-          <p:cNvPr id="37" name="TextBox 36"/>
+              <a:t>TAM, SAM e SOM são as siglas do framework, à direita de cada faixa. A primeira versão projetava 24% do mercado atendível, assumindo turma de 100 alunos e adesão de 60% desde o T1.</a:t>
+            </a:r>
+          </a:p>
+        </p:txBody>
+      </p:sp>
+      <p:sp>
+        <p:nvSpPr>
+          <p:cNvPr id="43" name="TextBox 42"/>
           <p:cNvSpPr txBox="1"/>
           <p:nvPr/>
         </p:nvSpPr>
@@ -16326,7 +16536,7 @@
       </p:sp>
       <p:sp>
         <p:nvSpPr>
-          <p:cNvPr id="38" name="TextBox 37"/>
+          <p:cNvPr id="44" name="TextBox 43"/>
           <p:cNvSpPr txBox="1"/>
           <p:nvPr/>
         </p:nvSpPr>

</xml_diff>